<commit_message>
Chương 5: đổi nốt EC1103 -> EC6000TX trên mọi trang, sửa dòng "trực tiếp"
Trang bìa chỉ mới đổi dòng mã học phần ở lượt trước; lượt này đổi tiếp:
- Footer "EC1103" trên cả 20 trang nội dung còn lại của Chương 5.
- Dòng "Bài giảng biên soạn cho lớp giảng dạy trực tiếp" trên trang bìa
  (mâu thuẫn với "Hệ từ xa" ngay phía trên) -> "...cho lớp giảng dạy từ xa".

Nguồn sinh (design.js, build_ch5_practice.js, upgrade_decks.py,
apply_upgrade.py) đều thêm tham số mã học phần/chế độ lớp, mặc định vẫn
EC1103 + "trực tiếp" cho 7 deck còn lại (c1-c4, th1-th3) — chỉ Chương 5
dùng EC6000TX + "từ xa". Ảnh JPEG trong trình xem (assets/slides/ch5) và
video "ÔN TẬP CHƯƠNG 5" đã dựng lại khớp theo; video chỉ thay đúng đoạn
hình bìa (0-11s), âm thanh gốc giữ nguyên nên thời lượng không đổi. Nâng
PHIEN_BAN vì đổi nhiều tệp trong assets/ và videos/.
</commit_message>
<xml_diff>
--- a/slides/05-soan-thao-van-ban.pptx
+++ b/slides/05-soan-thao-van-ban.pptx
@@ -3097,7 +3097,7 @@
                 <a:ea typeface="Calibri" pitchFamily="34" charset="-122"/>
                 <a:cs typeface="Calibri" pitchFamily="34" charset="-120"/>
               </a:rPr>
-              <a:t>© Đỗ Thùy Hương, 2026 — Bài giảng biên soạn cho lớp giảng dạy trực tiếp. Vui lòng ghi nguồn khi sử dụng.</a:t>
+              <a:t>© Đỗ Thùy Hương, 2026 — Bài giảng biên soạn cho lớp giảng dạy từ xa. Vui lòng ghi nguồn khi sử dụng.</a:t>
             </a:r>
             <a:endParaRPr lang="en-US" sz="900" dirty="0"/>
           </a:p>
@@ -3683,7 +3683,7 @@
                 </a:solidFill>
                 <a:latin typeface="Calibri"/>
               </a:rPr>
-              <a:t>Je m'appelle Huong  •  GV. Đỗ Thùy Hương  •  EC1103</a:t>
+              <a:t>Je m'appelle Huong  •  GV. Đỗ Thùy Hương  •  EC6000TX</a:t>
             </a:r>
           </a:p>
         </p:txBody>
@@ -4004,7 +4004,7 @@
                 </a:solidFill>
                 <a:latin typeface="Calibri"/>
               </a:rPr>
-              <a:t>Je m'appelle Huong  •  GV. Đỗ Thùy Hương  •  EC1103</a:t>
+              <a:t>Je m'appelle Huong  •  GV. Đỗ Thùy Hương  •  EC6000TX</a:t>
             </a:r>
           </a:p>
         </p:txBody>
@@ -4133,7 +4133,7 @@
                 <a:ea typeface="Calibri" pitchFamily="34" charset="-122"/>
                 <a:cs typeface="Calibri" pitchFamily="34" charset="-120"/>
               </a:rPr>
-              <a:t>Je m'appelle Huong  •  GV. Đỗ Thùy Hương  •  EC1103</a:t>
+              <a:t>Je m'appelle Huong  •  GV. Đỗ Thùy Hương  •  EC6000TX</a:t>
             </a:r>
             <a:endParaRPr lang="en-US" sz="900" dirty="0"/>
           </a:p>
@@ -4467,7 +4467,7 @@
                 <a:ea typeface="Calibri" pitchFamily="34" charset="-122"/>
                 <a:cs typeface="Calibri" pitchFamily="34" charset="-120"/>
               </a:rPr>
-              <a:t>Je m'appelle Huong  •  GV. Đỗ Thùy Hương  •  EC1103</a:t>
+              <a:t>Je m'appelle Huong  •  GV. Đỗ Thùy Hương  •  EC6000TX</a:t>
             </a:r>
             <a:endParaRPr lang="en-US" sz="900" dirty="0"/>
           </a:p>
@@ -5090,7 +5090,7 @@
                 <a:ea typeface="Calibri" pitchFamily="34" charset="-122"/>
                 <a:cs typeface="Calibri" pitchFamily="34" charset="-120"/>
               </a:rPr>
-              <a:t>Je m'appelle Huong  •  GV. Đỗ Thùy Hương  •  EC1103</a:t>
+              <a:t>Je m'appelle Huong  •  GV. Đỗ Thùy Hương  •  EC6000TX</a:t>
             </a:r>
             <a:endParaRPr lang="en-US" sz="900" dirty="0"/>
           </a:p>
@@ -5818,7 +5818,7 @@
                 </a:solidFill>
                 <a:latin typeface="Calibri"/>
               </a:rPr>
-              <a:t>Je m'appelle Huong  •  GV. Đỗ Thùy Hương  •  EC1103</a:t>
+              <a:t>Je m'appelle Huong  •  GV. Đỗ Thùy Hương  •  EC6000TX</a:t>
             </a:r>
           </a:p>
         </p:txBody>
@@ -5947,7 +5947,7 @@
                 <a:ea typeface="Calibri" pitchFamily="34" charset="-122"/>
                 <a:cs typeface="Calibri" pitchFamily="34" charset="-120"/>
               </a:rPr>
-              <a:t>Je m'appelle Huong  •  GV. Đỗ Thùy Hương  •  EC1103</a:t>
+              <a:t>Je m'appelle Huong  •  GV. Đỗ Thùy Hương  •  EC6000TX</a:t>
             </a:r>
             <a:endParaRPr lang="en-US" sz="900" dirty="0"/>
           </a:p>
@@ -6570,7 +6570,7 @@
                 <a:ea typeface="Calibri" pitchFamily="34" charset="-122"/>
                 <a:cs typeface="Calibri" pitchFamily="34" charset="-120"/>
               </a:rPr>
-              <a:t>Je m'appelle Huong  •  GV. Đỗ Thùy Hương  •  EC1103</a:t>
+              <a:t>Je m'appelle Huong  •  GV. Đỗ Thùy Hương  •  EC6000TX</a:t>
             </a:r>
             <a:endParaRPr lang="en-US" sz="900" dirty="0"/>
           </a:p>
@@ -7106,7 +7106,7 @@
                 <a:ea typeface="Calibri" pitchFamily="34" charset="-122"/>
                 <a:cs typeface="Calibri" pitchFamily="34" charset="-120"/>
               </a:rPr>
-              <a:t>Je m'appelle Huong  •  GV. Đỗ Thùy Hương  •  EC1103</a:t>
+              <a:t>Je m'appelle Huong  •  GV. Đỗ Thùy Hương  •  EC6000TX</a:t>
             </a:r>
             <a:endParaRPr lang="en-US" sz="900" dirty="0"/>
           </a:p>
@@ -7837,7 +7837,7 @@
                 <a:ea typeface="Calibri" pitchFamily="34" charset="-122"/>
                 <a:cs typeface="Calibri" pitchFamily="34" charset="-120"/>
               </a:rPr>
-              <a:t>Je m'appelle Huong  •  GV. Đỗ Thùy Hương  •  EC1103</a:t>
+              <a:t>Je m'appelle Huong  •  GV. Đỗ Thùy Hương  •  EC6000TX</a:t>
             </a:r>
             <a:endParaRPr lang="en-US" sz="900" dirty="0"/>
           </a:p>
@@ -8373,7 +8373,7 @@
                 <a:ea typeface="Calibri" pitchFamily="34" charset="-122"/>
                 <a:cs typeface="Calibri" pitchFamily="34" charset="-120"/>
               </a:rPr>
-              <a:t>Je m'appelle Huong  •  GV. Đỗ Thùy Hương  •  EC1103</a:t>
+              <a:t>Je m'appelle Huong  •  GV. Đỗ Thùy Hương  •  EC6000TX</a:t>
             </a:r>
             <a:endParaRPr lang="en-US" sz="900" dirty="0"/>
           </a:p>
@@ -9112,7 +9112,7 @@
                 <a:ea typeface="Calibri" pitchFamily="34" charset="-122"/>
                 <a:cs typeface="Calibri" pitchFamily="34" charset="-120"/>
               </a:rPr>
-              <a:t>Je m'appelle Huong  •  GV. Đỗ Thùy Hương  •  EC1103</a:t>
+              <a:t>Je m'appelle Huong  •  GV. Đỗ Thùy Hương  •  EC6000TX</a:t>
             </a:r>
             <a:endParaRPr lang="en-US" sz="900" dirty="0"/>
           </a:p>
@@ -9879,7 +9879,7 @@
                 <a:ea typeface="Calibri" pitchFamily="34" charset="-122"/>
                 <a:cs typeface="Calibri" pitchFamily="34" charset="-120"/>
               </a:rPr>
-              <a:t>Je m'appelle Huong  •  GV. Đỗ Thùy Hương  •  EC1103</a:t>
+              <a:t>Je m'appelle Huong  •  GV. Đỗ Thùy Hương  •  EC6000TX</a:t>
             </a:r>
             <a:endParaRPr lang="en-US" sz="900" dirty="0"/>
           </a:p>
@@ -10415,7 +10415,7 @@
                 <a:ea typeface="Calibri" pitchFamily="34" charset="-122"/>
                 <a:cs typeface="Calibri" pitchFamily="34" charset="-120"/>
               </a:rPr>
-              <a:t>Je m'appelle Huong  •  GV. Đỗ Thùy Hương  •  EC1103</a:t>
+              <a:t>Je m'appelle Huong  •  GV. Đỗ Thùy Hương  •  EC6000TX</a:t>
             </a:r>
             <a:endParaRPr lang="en-US" sz="900" dirty="0"/>
           </a:p>
@@ -11346,7 +11346,7 @@
                 </a:solidFill>
                 <a:latin typeface="Calibri"/>
               </a:rPr>
-              <a:t>Je m'appelle Huong  •  GV. Đỗ Thùy Hương  •  EC1103</a:t>
+              <a:t>Je m'appelle Huong  •  GV. Đỗ Thùy Hương  •  EC6000TX</a:t>
             </a:r>
           </a:p>
         </p:txBody>
@@ -11475,7 +11475,7 @@
                 <a:ea typeface="Calibri" pitchFamily="34" charset="-122"/>
                 <a:cs typeface="Calibri" pitchFamily="34" charset="-120"/>
               </a:rPr>
-              <a:t>Je m'appelle Huong  •  GV. Đỗ Thùy Hương  •  EC1103</a:t>
+              <a:t>Je m'appelle Huong  •  GV. Đỗ Thùy Hương  •  EC6000TX</a:t>
             </a:r>
             <a:endParaRPr lang="en-US" sz="900" dirty="0"/>
           </a:p>
@@ -12011,7 +12011,7 @@
                 <a:ea typeface="Calibri" pitchFamily="34" charset="-122"/>
                 <a:cs typeface="Calibri" pitchFamily="34" charset="-120"/>
               </a:rPr>
-              <a:t>Je m'appelle Huong  •  GV. Đỗ Thùy Hương  •  EC1103</a:t>
+              <a:t>Je m'appelle Huong  •  GV. Đỗ Thùy Hương  •  EC6000TX</a:t>
             </a:r>
             <a:endParaRPr lang="en-US" sz="900" dirty="0"/>
           </a:p>
@@ -12634,7 +12634,7 @@
                 <a:ea typeface="Calibri" pitchFamily="34" charset="-122"/>
                 <a:cs typeface="Calibri" pitchFamily="34" charset="-120"/>
               </a:rPr>
-              <a:t>Je m'appelle Huong  •  GV. Đỗ Thùy Hương  •  EC1103</a:t>
+              <a:t>Je m'appelle Huong  •  GV. Đỗ Thùy Hương  •  EC6000TX</a:t>
             </a:r>
             <a:endParaRPr lang="en-US" sz="900" dirty="0"/>
           </a:p>
@@ -13257,7 +13257,7 @@
                 <a:ea typeface="Calibri" pitchFamily="34" charset="-122"/>
                 <a:cs typeface="Calibri" pitchFamily="34" charset="-120"/>
               </a:rPr>
-              <a:t>Je m'appelle Huong  •  GV. Đỗ Thùy Hương  •  EC1103</a:t>
+              <a:t>Je m'appelle Huong  •  GV. Đỗ Thùy Hương  •  EC6000TX</a:t>
             </a:r>
             <a:endParaRPr lang="en-US" sz="900" dirty="0"/>
           </a:p>
@@ -13556,7 +13556,7 @@
                 <a:ea typeface="Calibri" pitchFamily="34" charset="-122"/>
                 <a:cs typeface="Calibri" pitchFamily="34" charset="-120"/>
               </a:rPr>
-              <a:t>Je m'appelle Huong  •  GV. Đỗ Thùy Hương  •  EC1103</a:t>
+              <a:t>Je m'appelle Huong  •  GV. Đỗ Thùy Hương  •  EC6000TX</a:t>
             </a:r>
             <a:endParaRPr lang="en-US" sz="900" dirty="0"/>
           </a:p>

</xml_diff>